<commit_message>
Upload de imagens e notebook catalogo
Upload notebook com catalogo de dados
</commit_message>
<xml_diff>
--- a/images/Esquemas.pptx
+++ b/images/Esquemas.pptx
@@ -2972,7 +2972,7 @@
         </p:nvSpPr>
         <p:spPr>
           <a:xfrm>
-            <a:off x="2341418" y="1820388"/>
+            <a:off x="2341418" y="1819563"/>
             <a:ext cx="1762298" cy="261610"/>
           </a:xfrm>
           <a:prstGeom prst="rect">
@@ -2986,6 +2986,7 @@
           </a:bodyPr>
           <a:lstStyle/>
           <a:p>
+            <a:pPr algn="ctr"/>
             <a:r>
               <a:rPr lang="pt-BR" sz="1100" dirty="0" smtClean="0"/>
               <a:t>Dados Saeb</a:t>
@@ -3002,7 +3003,7 @@
         </p:nvSpPr>
         <p:spPr>
           <a:xfrm>
-            <a:off x="3315766" y="1814117"/>
+            <a:off x="3557156" y="1819563"/>
             <a:ext cx="1762298" cy="261610"/>
           </a:xfrm>
           <a:prstGeom prst="rect">
@@ -3016,6 +3017,7 @@
           </a:bodyPr>
           <a:lstStyle/>
           <a:p>
+            <a:pPr algn="ctr"/>
             <a:r>
               <a:rPr lang="pt-BR" sz="1100" dirty="0" smtClean="0"/>
               <a:t>Dados socioeconômicos</a:t>
@@ -3032,7 +3034,7 @@
         </p:nvSpPr>
         <p:spPr>
           <a:xfrm>
-            <a:off x="4937759" y="1803889"/>
+            <a:off x="4937759" y="1819563"/>
             <a:ext cx="1762298" cy="261610"/>
           </a:xfrm>
           <a:prstGeom prst="rect">
@@ -3046,6 +3048,7 @@
           </a:bodyPr>
           <a:lstStyle/>
           <a:p>
+            <a:pPr algn="ctr"/>
             <a:r>
               <a:rPr lang="pt-BR" sz="1100" dirty="0" smtClean="0"/>
               <a:t>Atributos estados</a:t>

</xml_diff>

<commit_message>
Upload de imagens e atualização do readme
</commit_message>
<xml_diff>
--- a/images/Esquemas.pptx
+++ b/images/Esquemas.pptx
@@ -6,6 +6,7 @@
   </p:sldMasterIdLst>
   <p:sldIdLst>
     <p:sldId id="256" r:id="rId2"/>
+    <p:sldId id="257" r:id="rId3"/>
   </p:sldIdLst>
   <p:sldSz cx="12192000" cy="6858000"/>
   <p:notesSz cx="6858000" cy="9144000"/>
@@ -104,6 +105,11 @@
       </a:defRPr>
     </a:lvl9pPr>
   </p:defaultTextStyle>
+  <p:extLst>
+    <p:ext uri="{EFAFB233-063F-42B5-8137-9DF3F51BA10A}">
+      <p15:sldGuideLst xmlns:p15="http://schemas.microsoft.com/office/powerpoint/2012/main"/>
+    </p:ext>
+  </p:extLst>
 </p:presentation>
 </file>
 
@@ -238,7 +244,7 @@
           <a:p>
             <a:fld id="{1E311FA7-6BA6-4A2F-9BAD-8242EC82DFBC}" type="datetimeFigureOut">
               <a:rPr lang="pt-BR" smtClean="0"/>
-              <a:t>21/09/2026</a:t>
+              <a:t>23/09/2026</a:t>
             </a:fld>
             <a:endParaRPr lang="pt-BR"/>
           </a:p>
@@ -408,7 +414,7 @@
           <a:p>
             <a:fld id="{1E311FA7-6BA6-4A2F-9BAD-8242EC82DFBC}" type="datetimeFigureOut">
               <a:rPr lang="pt-BR" smtClean="0"/>
-              <a:t>21/09/2026</a:t>
+              <a:t>23/09/2026</a:t>
             </a:fld>
             <a:endParaRPr lang="pt-BR"/>
           </a:p>
@@ -588,7 +594,7 @@
           <a:p>
             <a:fld id="{1E311FA7-6BA6-4A2F-9BAD-8242EC82DFBC}" type="datetimeFigureOut">
               <a:rPr lang="pt-BR" smtClean="0"/>
-              <a:t>21/09/2026</a:t>
+              <a:t>23/09/2026</a:t>
             </a:fld>
             <a:endParaRPr lang="pt-BR"/>
           </a:p>
@@ -758,7 +764,7 @@
           <a:p>
             <a:fld id="{1E311FA7-6BA6-4A2F-9BAD-8242EC82DFBC}" type="datetimeFigureOut">
               <a:rPr lang="pt-BR" smtClean="0"/>
-              <a:t>21/09/2026</a:t>
+              <a:t>23/09/2026</a:t>
             </a:fld>
             <a:endParaRPr lang="pt-BR"/>
           </a:p>
@@ -1004,7 +1010,7 @@
           <a:p>
             <a:fld id="{1E311FA7-6BA6-4A2F-9BAD-8242EC82DFBC}" type="datetimeFigureOut">
               <a:rPr lang="pt-BR" smtClean="0"/>
-              <a:t>21/09/2026</a:t>
+              <a:t>23/09/2026</a:t>
             </a:fld>
             <a:endParaRPr lang="pt-BR"/>
           </a:p>
@@ -1236,7 +1242,7 @@
           <a:p>
             <a:fld id="{1E311FA7-6BA6-4A2F-9BAD-8242EC82DFBC}" type="datetimeFigureOut">
               <a:rPr lang="pt-BR" smtClean="0"/>
-              <a:t>21/09/2026</a:t>
+              <a:t>23/09/2026</a:t>
             </a:fld>
             <a:endParaRPr lang="pt-BR"/>
           </a:p>
@@ -1603,7 +1609,7 @@
           <a:p>
             <a:fld id="{1E311FA7-6BA6-4A2F-9BAD-8242EC82DFBC}" type="datetimeFigureOut">
               <a:rPr lang="pt-BR" smtClean="0"/>
-              <a:t>21/09/2026</a:t>
+              <a:t>23/09/2026</a:t>
             </a:fld>
             <a:endParaRPr lang="pt-BR"/>
           </a:p>
@@ -1721,7 +1727,7 @@
           <a:p>
             <a:fld id="{1E311FA7-6BA6-4A2F-9BAD-8242EC82DFBC}" type="datetimeFigureOut">
               <a:rPr lang="pt-BR" smtClean="0"/>
-              <a:t>21/09/2026</a:t>
+              <a:t>23/09/2026</a:t>
             </a:fld>
             <a:endParaRPr lang="pt-BR"/>
           </a:p>
@@ -1816,7 +1822,7 @@
           <a:p>
             <a:fld id="{1E311FA7-6BA6-4A2F-9BAD-8242EC82DFBC}" type="datetimeFigureOut">
               <a:rPr lang="pt-BR" smtClean="0"/>
-              <a:t>21/09/2026</a:t>
+              <a:t>23/09/2026</a:t>
             </a:fld>
             <a:endParaRPr lang="pt-BR"/>
           </a:p>
@@ -2093,7 +2099,7 @@
           <a:p>
             <a:fld id="{1E311FA7-6BA6-4A2F-9BAD-8242EC82DFBC}" type="datetimeFigureOut">
               <a:rPr lang="pt-BR" smtClean="0"/>
-              <a:t>21/09/2026</a:t>
+              <a:t>23/09/2026</a:t>
             </a:fld>
             <a:endParaRPr lang="pt-BR"/>
           </a:p>
@@ -2346,7 +2352,7 @@
           <a:p>
             <a:fld id="{1E311FA7-6BA6-4A2F-9BAD-8242EC82DFBC}" type="datetimeFigureOut">
               <a:rPr lang="pt-BR" smtClean="0"/>
-              <a:t>21/09/2026</a:t>
+              <a:t>23/09/2026</a:t>
             </a:fld>
             <a:endParaRPr lang="pt-BR"/>
           </a:p>
@@ -2559,7 +2565,7 @@
           <a:p>
             <a:fld id="{1E311FA7-6BA6-4A2F-9BAD-8242EC82DFBC}" type="datetimeFigureOut">
               <a:rPr lang="pt-BR" smtClean="0"/>
-              <a:t>21/09/2026</a:t>
+              <a:t>23/09/2026</a:t>
             </a:fld>
             <a:endParaRPr lang="pt-BR"/>
           </a:p>
@@ -3204,7 +3210,7 @@
               <a:buChar char="•"/>
             </a:pPr>
             <a:r>
-              <a:rPr lang="pt-BR" sz="1400" dirty="0" err="1" smtClean="0"/>
+              <a:rPr lang="pt-BR" sz="1400" dirty="0" smtClean="0"/>
               <a:t>resultado_saeb_por_tipo_de_escola</a:t>
             </a:r>
             <a:endParaRPr lang="pt-BR" dirty="0"/>
@@ -3830,6 +3836,1273 @@
     <p:extLst>
       <p:ext uri="{BB962C8B-B14F-4D97-AF65-F5344CB8AC3E}">
         <p14:creationId xmlns:p14="http://schemas.microsoft.com/office/powerpoint/2010/main" val="675852118"/>
+      </p:ext>
+    </p:extLst>
+  </p:cSld>
+  <p:clrMapOvr>
+    <a:masterClrMapping/>
+  </p:clrMapOvr>
+</p:sld>
+</file>
+
+<file path=ppt/slides/slide2.xml><?xml version="1.0" encoding="utf-8"?>
+<p:sld xmlns:a="http://schemas.openxmlformats.org/drawingml/2006/main" xmlns:r="http://schemas.openxmlformats.org/officeDocument/2006/relationships" xmlns:p="http://schemas.openxmlformats.org/presentationml/2006/main">
+  <p:cSld>
+    <p:spTree>
+      <p:nvGrpSpPr>
+        <p:cNvPr id="1" name=""/>
+        <p:cNvGrpSpPr/>
+        <p:nvPr/>
+      </p:nvGrpSpPr>
+      <p:grpSpPr>
+        <a:xfrm>
+          <a:off x="0" y="0"/>
+          <a:ext cx="0" cy="0"/>
+          <a:chOff x="0" y="0"/>
+          <a:chExt cx="0" cy="0"/>
+        </a:xfrm>
+      </p:grpSpPr>
+      <p:graphicFrame>
+        <p:nvGraphicFramePr>
+          <p:cNvPr id="4" name="Tabela 3"/>
+          <p:cNvGraphicFramePr>
+            <a:graphicFrameLocks noGrp="1"/>
+          </p:cNvGraphicFramePr>
+          <p:nvPr/>
+        </p:nvGraphicFramePr>
+        <p:xfrm>
+          <a:off x="1150850" y="594975"/>
+          <a:ext cx="2357120" cy="1645920"/>
+        </p:xfrm>
+        <a:graphic>
+          <a:graphicData uri="http://schemas.openxmlformats.org/drawingml/2006/table">
+            <a:tbl>
+              <a:tblPr firstRow="1" bandRow="1">
+                <a:tableStyleId>{5C22544A-7EE6-4342-B048-85BDC9FD1C3A}</a:tableStyleId>
+              </a:tblPr>
+              <a:tblGrid>
+                <a:gridCol w="2357120"/>
+              </a:tblGrid>
+              <a:tr h="222263">
+                <a:tc>
+                  <a:txBody>
+                    <a:bodyPr/>
+                    <a:lstStyle/>
+                    <a:p>
+                      <a:r>
+                        <a:rPr lang="pt-BR" sz="1200" dirty="0" smtClean="0"/>
+                        <a:t>silver.resultados_saeb</a:t>
+                      </a:r>
+                      <a:endParaRPr lang="pt-BR" sz="1200" dirty="0"/>
+                    </a:p>
+                  </a:txBody>
+                  <a:tcPr/>
+                </a:tc>
+              </a:tr>
+              <a:tr h="222263">
+                <a:tc>
+                  <a:txBody>
+                    <a:bodyPr/>
+                    <a:lstStyle/>
+                    <a:p>
+                      <a:r>
+                        <a:rPr lang="pt-BR" sz="1200" kern="1200" dirty="0" smtClean="0">
+                          <a:solidFill>
+                            <a:schemeClr val="dk1"/>
+                          </a:solidFill>
+                          <a:latin typeface="+mn-lt"/>
+                          <a:ea typeface="+mn-ea"/>
+                          <a:cs typeface="+mn-cs"/>
+                        </a:rPr>
+                        <a:t>ESTADO</a:t>
+                      </a:r>
+                      <a:endParaRPr lang="pt-BR" sz="1200" kern="1200" dirty="0">
+                        <a:solidFill>
+                          <a:schemeClr val="dk1"/>
+                        </a:solidFill>
+                        <a:latin typeface="+mn-lt"/>
+                        <a:ea typeface="+mn-ea"/>
+                        <a:cs typeface="+mn-cs"/>
+                      </a:endParaRPr>
+                    </a:p>
+                  </a:txBody>
+                  <a:tcPr/>
+                </a:tc>
+              </a:tr>
+              <a:tr h="222263">
+                <a:tc>
+                  <a:txBody>
+                    <a:bodyPr/>
+                    <a:lstStyle/>
+                    <a:p>
+                      <a:r>
+                        <a:rPr lang="pt-BR" sz="1200" kern="1200" dirty="0" smtClean="0">
+                          <a:solidFill>
+                            <a:schemeClr val="dk1"/>
+                          </a:solidFill>
+                          <a:latin typeface="+mn-lt"/>
+                          <a:ea typeface="+mn-ea"/>
+                          <a:cs typeface="+mn-cs"/>
+                        </a:rPr>
+                        <a:t>ID_SAEB</a:t>
+                      </a:r>
+                      <a:endParaRPr lang="pt-BR" sz="1200" kern="1200" dirty="0">
+                        <a:solidFill>
+                          <a:schemeClr val="dk1"/>
+                        </a:solidFill>
+                        <a:latin typeface="+mn-lt"/>
+                        <a:ea typeface="+mn-ea"/>
+                        <a:cs typeface="+mn-cs"/>
+                      </a:endParaRPr>
+                    </a:p>
+                  </a:txBody>
+                  <a:tcPr/>
+                </a:tc>
+              </a:tr>
+              <a:tr h="222263">
+                <a:tc>
+                  <a:txBody>
+                    <a:bodyPr/>
+                    <a:lstStyle/>
+                    <a:p>
+                      <a:r>
+                        <a:rPr lang="pt-BR" sz="1200" kern="1200" dirty="0" smtClean="0">
+                          <a:solidFill>
+                            <a:schemeClr val="dk1"/>
+                          </a:solidFill>
+                          <a:latin typeface="+mn-lt"/>
+                          <a:ea typeface="+mn-ea"/>
+                          <a:cs typeface="+mn-cs"/>
+                        </a:rPr>
+                        <a:t>ID_MUNICIPIO</a:t>
+                      </a:r>
+                      <a:endParaRPr lang="pt-BR" sz="1200" kern="1200" dirty="0">
+                        <a:solidFill>
+                          <a:schemeClr val="dk1"/>
+                        </a:solidFill>
+                        <a:latin typeface="+mn-lt"/>
+                        <a:ea typeface="+mn-ea"/>
+                        <a:cs typeface="+mn-cs"/>
+                      </a:endParaRPr>
+                    </a:p>
+                  </a:txBody>
+                  <a:tcPr/>
+                </a:tc>
+              </a:tr>
+              <a:tr h="222263">
+                <a:tc>
+                  <a:txBody>
+                    <a:bodyPr/>
+                    <a:lstStyle/>
+                    <a:p>
+                      <a:r>
+                        <a:rPr lang="pt-BR" sz="1200" kern="1200" dirty="0" smtClean="0">
+                          <a:solidFill>
+                            <a:schemeClr val="dk1"/>
+                          </a:solidFill>
+                          <a:latin typeface="+mn-lt"/>
+                          <a:ea typeface="+mn-ea"/>
+                          <a:cs typeface="+mn-cs"/>
+                        </a:rPr>
+                        <a:t>ID_ESCOLA</a:t>
+                      </a:r>
+                      <a:endParaRPr lang="pt-BR" sz="1200" kern="1200" dirty="0">
+                        <a:solidFill>
+                          <a:schemeClr val="dk1"/>
+                        </a:solidFill>
+                        <a:latin typeface="+mn-lt"/>
+                        <a:ea typeface="+mn-ea"/>
+                        <a:cs typeface="+mn-cs"/>
+                      </a:endParaRPr>
+                    </a:p>
+                  </a:txBody>
+                  <a:tcPr/>
+                </a:tc>
+              </a:tr>
+              <a:tr h="222263">
+                <a:tc>
+                  <a:txBody>
+                    <a:bodyPr/>
+                    <a:lstStyle/>
+                    <a:p>
+                      <a:r>
+                        <a:rPr lang="pt-BR" sz="1200" kern="1200" dirty="0" smtClean="0">
+                          <a:solidFill>
+                            <a:schemeClr val="dk1"/>
+                          </a:solidFill>
+                          <a:latin typeface="+mn-lt"/>
+                          <a:ea typeface="+mn-ea"/>
+                          <a:cs typeface="+mn-cs"/>
+                        </a:rPr>
+                        <a:t>NIVEL_SOCIO_ECONOMICO</a:t>
+                      </a:r>
+                      <a:endParaRPr lang="pt-BR" sz="1200" kern="1200" dirty="0">
+                        <a:solidFill>
+                          <a:schemeClr val="dk1"/>
+                        </a:solidFill>
+                        <a:latin typeface="+mn-lt"/>
+                        <a:ea typeface="+mn-ea"/>
+                        <a:cs typeface="+mn-cs"/>
+                      </a:endParaRPr>
+                    </a:p>
+                  </a:txBody>
+                  <a:tcPr/>
+                </a:tc>
+              </a:tr>
+            </a:tbl>
+          </a:graphicData>
+        </a:graphic>
+      </p:graphicFrame>
+      <p:graphicFrame>
+        <p:nvGraphicFramePr>
+          <p:cNvPr id="5" name="Tabela 4"/>
+          <p:cNvGraphicFramePr>
+            <a:graphicFrameLocks noGrp="1"/>
+          </p:cNvGraphicFramePr>
+          <p:nvPr/>
+        </p:nvGraphicFramePr>
+        <p:xfrm>
+          <a:off x="4708696" y="2150840"/>
+          <a:ext cx="2357120" cy="822960"/>
+        </p:xfrm>
+        <a:graphic>
+          <a:graphicData uri="http://schemas.openxmlformats.org/drawingml/2006/table">
+            <a:tbl>
+              <a:tblPr firstRow="1" bandRow="1">
+                <a:tableStyleId>{5C22544A-7EE6-4342-B048-85BDC9FD1C3A}</a:tableStyleId>
+              </a:tblPr>
+              <a:tblGrid>
+                <a:gridCol w="2357120"/>
+              </a:tblGrid>
+              <a:tr h="0">
+                <a:tc>
+                  <a:txBody>
+                    <a:bodyPr/>
+                    <a:lstStyle/>
+                    <a:p>
+                      <a:r>
+                        <a:rPr lang="pt-BR" sz="1200" dirty="0" smtClean="0"/>
+                        <a:t>bronze.atributos_estados</a:t>
+                      </a:r>
+                      <a:endParaRPr lang="pt-BR" sz="1200" dirty="0"/>
+                    </a:p>
+                  </a:txBody>
+                  <a:tcPr/>
+                </a:tc>
+              </a:tr>
+              <a:tr h="0">
+                <a:tc>
+                  <a:txBody>
+                    <a:bodyPr/>
+                    <a:lstStyle/>
+                    <a:p>
+                      <a:r>
+                        <a:rPr lang="pt-BR" sz="1200" dirty="0" smtClean="0"/>
+                        <a:t>Estado</a:t>
+                      </a:r>
+                      <a:endParaRPr lang="pt-BR" sz="1200" dirty="0"/>
+                    </a:p>
+                  </a:txBody>
+                  <a:tcPr/>
+                </a:tc>
+              </a:tr>
+              <a:tr h="0">
+                <a:tc>
+                  <a:txBody>
+                    <a:bodyPr/>
+                    <a:lstStyle/>
+                    <a:p>
+                      <a:r>
+                        <a:rPr lang="pt-BR" sz="1200" dirty="0" smtClean="0"/>
+                        <a:t>Região</a:t>
+                      </a:r>
+                      <a:endParaRPr lang="pt-BR" sz="1200" dirty="0"/>
+                    </a:p>
+                  </a:txBody>
+                  <a:tcPr/>
+                </a:tc>
+              </a:tr>
+            </a:tbl>
+          </a:graphicData>
+        </a:graphic>
+      </p:graphicFrame>
+      <p:graphicFrame>
+        <p:nvGraphicFramePr>
+          <p:cNvPr id="6" name="Tabela 5"/>
+          <p:cNvGraphicFramePr>
+            <a:graphicFrameLocks noGrp="1"/>
+          </p:cNvGraphicFramePr>
+          <p:nvPr/>
+        </p:nvGraphicFramePr>
+        <p:xfrm>
+          <a:off x="7914638" y="594975"/>
+          <a:ext cx="2850343" cy="1645920"/>
+        </p:xfrm>
+        <a:graphic>
+          <a:graphicData uri="http://schemas.openxmlformats.org/drawingml/2006/table">
+            <a:tbl>
+              <a:tblPr firstRow="1" bandRow="1">
+                <a:tableStyleId>{5C22544A-7EE6-4342-B048-85BDC9FD1C3A}</a:tableStyleId>
+              </a:tblPr>
+              <a:tblGrid>
+                <a:gridCol w="2850343"/>
+              </a:tblGrid>
+              <a:tr h="0">
+                <a:tc>
+                  <a:txBody>
+                    <a:bodyPr/>
+                    <a:lstStyle/>
+                    <a:p>
+                      <a:r>
+                        <a:rPr lang="pt-BR" sz="1200" dirty="0" smtClean="0"/>
+                        <a:t>Bronze.dados_socioeconomicos_estados</a:t>
+                      </a:r>
+                      <a:endParaRPr lang="pt-BR" sz="1200" dirty="0"/>
+                    </a:p>
+                  </a:txBody>
+                  <a:tcPr/>
+                </a:tc>
+              </a:tr>
+              <a:tr h="0">
+                <a:tc>
+                  <a:txBody>
+                    <a:bodyPr/>
+                    <a:lstStyle/>
+                    <a:p>
+                      <a:r>
+                        <a:rPr lang="pt-BR" sz="1200" dirty="0" smtClean="0"/>
+                        <a:t>ANO</a:t>
+                      </a:r>
+                      <a:endParaRPr lang="pt-BR" sz="1200" dirty="0"/>
+                    </a:p>
+                  </a:txBody>
+                  <a:tcPr/>
+                </a:tc>
+              </a:tr>
+              <a:tr h="0">
+                <a:tc>
+                  <a:txBody>
+                    <a:bodyPr/>
+                    <a:lstStyle/>
+                    <a:p>
+                      <a:r>
+                        <a:rPr lang="pt-BR" sz="1200" dirty="0" smtClean="0"/>
+                        <a:t>UFN</a:t>
+                      </a:r>
+                      <a:endParaRPr lang="pt-BR" sz="1200" dirty="0"/>
+                    </a:p>
+                  </a:txBody>
+                  <a:tcPr/>
+                </a:tc>
+              </a:tr>
+              <a:tr h="0">
+                <a:tc>
+                  <a:txBody>
+                    <a:bodyPr/>
+                    <a:lstStyle/>
+                    <a:p>
+                      <a:r>
+                        <a:rPr lang="pt-BR" sz="1200" kern="1200" dirty="0" smtClean="0">
+                          <a:solidFill>
+                            <a:schemeClr val="dk1"/>
+                          </a:solidFill>
+                          <a:latin typeface="+mn-lt"/>
+                          <a:ea typeface="+mn-ea"/>
+                          <a:cs typeface="+mn-cs"/>
+                        </a:rPr>
+                        <a:t>E_ANOSESTUDO</a:t>
+                      </a:r>
+                      <a:endParaRPr lang="pt-BR" sz="1200" kern="1200" dirty="0">
+                        <a:solidFill>
+                          <a:schemeClr val="dk1"/>
+                        </a:solidFill>
+                        <a:latin typeface="+mn-lt"/>
+                        <a:ea typeface="+mn-ea"/>
+                        <a:cs typeface="+mn-cs"/>
+                      </a:endParaRPr>
+                    </a:p>
+                  </a:txBody>
+                  <a:tcPr/>
+                </a:tc>
+              </a:tr>
+              <a:tr h="0">
+                <a:tc>
+                  <a:txBody>
+                    <a:bodyPr/>
+                    <a:lstStyle/>
+                    <a:p>
+                      <a:r>
+                        <a:rPr lang="pt-BR" sz="1200" kern="1200" dirty="0" smtClean="0">
+                          <a:solidFill>
+                            <a:schemeClr val="dk1"/>
+                          </a:solidFill>
+                          <a:latin typeface="+mn-lt"/>
+                          <a:ea typeface="+mn-ea"/>
+                          <a:cs typeface="+mn-cs"/>
+                        </a:rPr>
+                        <a:t>GINI</a:t>
+                      </a:r>
+                      <a:endParaRPr lang="pt-BR" sz="1200" kern="1200" dirty="0">
+                        <a:solidFill>
+                          <a:schemeClr val="dk1"/>
+                        </a:solidFill>
+                        <a:latin typeface="+mn-lt"/>
+                        <a:ea typeface="+mn-ea"/>
+                        <a:cs typeface="+mn-cs"/>
+                      </a:endParaRPr>
+                    </a:p>
+                  </a:txBody>
+                  <a:tcPr/>
+                </a:tc>
+              </a:tr>
+              <a:tr h="0">
+                <a:tc>
+                  <a:txBody>
+                    <a:bodyPr/>
+                    <a:lstStyle/>
+                    <a:p>
+                      <a:r>
+                        <a:rPr lang="pt-BR" sz="1200" kern="1200" dirty="0" smtClean="0">
+                          <a:solidFill>
+                            <a:schemeClr val="dk1"/>
+                          </a:solidFill>
+                          <a:latin typeface="+mn-lt"/>
+                          <a:ea typeface="+mn-ea"/>
+                          <a:cs typeface="+mn-cs"/>
+                        </a:rPr>
+                        <a:t>RDPC</a:t>
+                      </a:r>
+                      <a:endParaRPr lang="pt-BR" sz="1200" kern="1200" dirty="0">
+                        <a:solidFill>
+                          <a:schemeClr val="dk1"/>
+                        </a:solidFill>
+                        <a:latin typeface="+mn-lt"/>
+                        <a:ea typeface="+mn-ea"/>
+                        <a:cs typeface="+mn-cs"/>
+                      </a:endParaRPr>
+                    </a:p>
+                  </a:txBody>
+                  <a:tcPr/>
+                </a:tc>
+              </a:tr>
+            </a:tbl>
+          </a:graphicData>
+        </a:graphic>
+      </p:graphicFrame>
+      <p:graphicFrame>
+        <p:nvGraphicFramePr>
+          <p:cNvPr id="7" name="Tabela 6"/>
+          <p:cNvGraphicFramePr>
+            <a:graphicFrameLocks noGrp="1"/>
+          </p:cNvGraphicFramePr>
+          <p:nvPr/>
+        </p:nvGraphicFramePr>
+        <p:xfrm>
+          <a:off x="8058726" y="4459007"/>
+          <a:ext cx="3329710" cy="1371600"/>
+        </p:xfrm>
+        <a:graphic>
+          <a:graphicData uri="http://schemas.openxmlformats.org/drawingml/2006/table">
+            <a:tbl>
+              <a:tblPr firstRow="1" bandRow="1">
+                <a:tableStyleId>{5C22544A-7EE6-4342-B048-85BDC9FD1C3A}</a:tableStyleId>
+              </a:tblPr>
+              <a:tblGrid>
+                <a:gridCol w="3329710"/>
+              </a:tblGrid>
+              <a:tr h="0">
+                <a:tc>
+                  <a:txBody>
+                    <a:bodyPr/>
+                    <a:lstStyle/>
+                    <a:p>
+                      <a:pPr marL="0" algn="l" defTabSz="914400" rtl="0" eaLnBrk="1" latinLnBrk="0" hangingPunct="1"/>
+                      <a:r>
+                        <a:rPr lang="pt-BR" sz="1200" b="1" kern="1200" dirty="0" smtClean="0">
+                          <a:solidFill>
+                            <a:schemeClr val="lt1"/>
+                          </a:solidFill>
+                          <a:latin typeface="+mn-lt"/>
+                          <a:ea typeface="+mn-ea"/>
+                          <a:cs typeface="+mn-cs"/>
+                        </a:rPr>
+                        <a:t>Gold. resultado_saeb_por_tipo_de_escola</a:t>
+                      </a:r>
+                      <a:endParaRPr lang="pt-BR" sz="1200" dirty="0"/>
+                    </a:p>
+                  </a:txBody>
+                  <a:tcPr/>
+                </a:tc>
+              </a:tr>
+              <a:tr h="0">
+                <a:tc>
+                  <a:txBody>
+                    <a:bodyPr/>
+                    <a:lstStyle/>
+                    <a:p>
+                      <a:r>
+                        <a:rPr lang="pt-BR" sz="1200" kern="1200" dirty="0" smtClean="0">
+                          <a:solidFill>
+                            <a:schemeClr val="dk1"/>
+                          </a:solidFill>
+                          <a:latin typeface="+mn-lt"/>
+                          <a:ea typeface="+mn-ea"/>
+                          <a:cs typeface="+mn-cs"/>
+                        </a:rPr>
+                        <a:t>escola_publica</a:t>
+                      </a:r>
+                      <a:endParaRPr lang="pt-BR" sz="1200" kern="1200" dirty="0">
+                        <a:solidFill>
+                          <a:schemeClr val="dk1"/>
+                        </a:solidFill>
+                        <a:latin typeface="+mn-lt"/>
+                        <a:ea typeface="+mn-ea"/>
+                        <a:cs typeface="+mn-cs"/>
+                      </a:endParaRPr>
+                    </a:p>
+                  </a:txBody>
+                  <a:tcPr/>
+                </a:tc>
+              </a:tr>
+              <a:tr h="0">
+                <a:tc>
+                  <a:txBody>
+                    <a:bodyPr/>
+                    <a:lstStyle/>
+                    <a:p>
+                      <a:r>
+                        <a:rPr lang="pt-BR" sz="1200" kern="1200" dirty="0" smtClean="0">
+                          <a:solidFill>
+                            <a:schemeClr val="dk1"/>
+                          </a:solidFill>
+                          <a:latin typeface="+mn-lt"/>
+                          <a:ea typeface="+mn-ea"/>
+                          <a:cs typeface="+mn-cs"/>
+                        </a:rPr>
+                        <a:t>quantidade_escolas</a:t>
+                      </a:r>
+                      <a:endParaRPr lang="pt-BR" sz="1200" kern="1200" dirty="0">
+                        <a:solidFill>
+                          <a:schemeClr val="dk1"/>
+                        </a:solidFill>
+                        <a:latin typeface="+mn-lt"/>
+                        <a:ea typeface="+mn-ea"/>
+                        <a:cs typeface="+mn-cs"/>
+                      </a:endParaRPr>
+                    </a:p>
+                  </a:txBody>
+                  <a:tcPr/>
+                </a:tc>
+              </a:tr>
+              <a:tr h="0">
+                <a:tc>
+                  <a:txBody>
+                    <a:bodyPr/>
+                    <a:lstStyle/>
+                    <a:p>
+                      <a:r>
+                        <a:rPr lang="pt-BR" sz="1200" kern="1200" dirty="0" smtClean="0">
+                          <a:solidFill>
+                            <a:schemeClr val="dk1"/>
+                          </a:solidFill>
+                          <a:latin typeface="+mn-lt"/>
+                          <a:ea typeface="+mn-ea"/>
+                          <a:cs typeface="+mn-cs"/>
+                        </a:rPr>
+                        <a:t>media_9EF_LP</a:t>
+                      </a:r>
+                      <a:endParaRPr lang="pt-BR" sz="1200" kern="1200" dirty="0">
+                        <a:solidFill>
+                          <a:schemeClr val="dk1"/>
+                        </a:solidFill>
+                        <a:latin typeface="+mn-lt"/>
+                        <a:ea typeface="+mn-ea"/>
+                        <a:cs typeface="+mn-cs"/>
+                      </a:endParaRPr>
+                    </a:p>
+                  </a:txBody>
+                  <a:tcPr/>
+                </a:tc>
+              </a:tr>
+              <a:tr h="0">
+                <a:tc>
+                  <a:txBody>
+                    <a:bodyPr/>
+                    <a:lstStyle/>
+                    <a:p>
+                      <a:r>
+                        <a:rPr lang="pt-BR" sz="1200" kern="1200" dirty="0" smtClean="0">
+                          <a:solidFill>
+                            <a:schemeClr val="dk1"/>
+                          </a:solidFill>
+                          <a:latin typeface="+mn-lt"/>
+                          <a:ea typeface="+mn-ea"/>
+                          <a:cs typeface="+mn-cs"/>
+                        </a:rPr>
+                        <a:t>media_9EF_MT</a:t>
+                      </a:r>
+                      <a:endParaRPr lang="pt-BR" sz="1200" kern="1200" dirty="0">
+                        <a:solidFill>
+                          <a:schemeClr val="dk1"/>
+                        </a:solidFill>
+                        <a:latin typeface="+mn-lt"/>
+                        <a:ea typeface="+mn-ea"/>
+                        <a:cs typeface="+mn-cs"/>
+                      </a:endParaRPr>
+                    </a:p>
+                  </a:txBody>
+                  <a:tcPr/>
+                </a:tc>
+              </a:tr>
+            </a:tbl>
+          </a:graphicData>
+        </a:graphic>
+      </p:graphicFrame>
+      <p:graphicFrame>
+        <p:nvGraphicFramePr>
+          <p:cNvPr id="8" name="Tabela 7"/>
+          <p:cNvGraphicFramePr>
+            <a:graphicFrameLocks noGrp="1"/>
+          </p:cNvGraphicFramePr>
+          <p:nvPr/>
+        </p:nvGraphicFramePr>
+        <p:xfrm>
+          <a:off x="4459314" y="4459007"/>
+          <a:ext cx="3379588" cy="1645920"/>
+        </p:xfrm>
+        <a:graphic>
+          <a:graphicData uri="http://schemas.openxmlformats.org/drawingml/2006/table">
+            <a:tbl>
+              <a:tblPr firstRow="1" bandRow="1">
+                <a:tableStyleId>{5C22544A-7EE6-4342-B048-85BDC9FD1C3A}</a:tableStyleId>
+              </a:tblPr>
+              <a:tblGrid>
+                <a:gridCol w="3379588"/>
+              </a:tblGrid>
+              <a:tr h="0">
+                <a:tc>
+                  <a:txBody>
+                    <a:bodyPr/>
+                    <a:lstStyle/>
+                    <a:p>
+                      <a:r>
+                        <a:rPr lang="pt-BR" sz="1200" b="1" kern="1200" dirty="0" smtClean="0">
+                          <a:solidFill>
+                            <a:schemeClr val="lt1"/>
+                          </a:solidFill>
+                          <a:latin typeface="+mn-lt"/>
+                          <a:ea typeface="+mn-ea"/>
+                          <a:cs typeface="+mn-cs"/>
+                        </a:rPr>
+                        <a:t>Gold. resultado_saeb_por_nivel_socioeconomico</a:t>
+                      </a:r>
+                      <a:endParaRPr lang="pt-BR" sz="1200" dirty="0"/>
+                    </a:p>
+                  </a:txBody>
+                  <a:tcPr/>
+                </a:tc>
+              </a:tr>
+              <a:tr h="0">
+                <a:tc>
+                  <a:txBody>
+                    <a:bodyPr/>
+                    <a:lstStyle/>
+                    <a:p>
+                      <a:r>
+                        <a:rPr lang="pt-BR" sz="1200" kern="1200" dirty="0" smtClean="0">
+                          <a:solidFill>
+                            <a:schemeClr val="dk1"/>
+                          </a:solidFill>
+                          <a:latin typeface="+mn-lt"/>
+                          <a:ea typeface="+mn-ea"/>
+                          <a:cs typeface="+mn-cs"/>
+                        </a:rPr>
+                        <a:t>NIVEL_SOCIO_ECONOMICO</a:t>
+                      </a:r>
+                      <a:endParaRPr lang="pt-BR" sz="1200" kern="1200" dirty="0">
+                        <a:solidFill>
+                          <a:schemeClr val="dk1"/>
+                        </a:solidFill>
+                        <a:latin typeface="+mn-lt"/>
+                        <a:ea typeface="+mn-ea"/>
+                        <a:cs typeface="+mn-cs"/>
+                      </a:endParaRPr>
+                    </a:p>
+                  </a:txBody>
+                  <a:tcPr/>
+                </a:tc>
+              </a:tr>
+              <a:tr h="0">
+                <a:tc>
+                  <a:txBody>
+                    <a:bodyPr/>
+                    <a:lstStyle/>
+                    <a:p>
+                      <a:r>
+                        <a:rPr lang="pt-BR" sz="1200" kern="1200" dirty="0" smtClean="0">
+                          <a:solidFill>
+                            <a:schemeClr val="dk1"/>
+                          </a:solidFill>
+                          <a:latin typeface="+mn-lt"/>
+                          <a:ea typeface="+mn-ea"/>
+                          <a:cs typeface="+mn-cs"/>
+                        </a:rPr>
+                        <a:t>quantidade_escolas</a:t>
+                      </a:r>
+                      <a:endParaRPr lang="pt-BR" sz="1200" kern="1200" dirty="0">
+                        <a:solidFill>
+                          <a:schemeClr val="dk1"/>
+                        </a:solidFill>
+                        <a:latin typeface="+mn-lt"/>
+                        <a:ea typeface="+mn-ea"/>
+                        <a:cs typeface="+mn-cs"/>
+                      </a:endParaRPr>
+                    </a:p>
+                  </a:txBody>
+                  <a:tcPr/>
+                </a:tc>
+              </a:tr>
+              <a:tr h="0">
+                <a:tc>
+                  <a:txBody>
+                    <a:bodyPr/>
+                    <a:lstStyle/>
+                    <a:p>
+                      <a:r>
+                        <a:rPr lang="pt-BR" sz="1200" kern="1200" dirty="0" smtClean="0">
+                          <a:solidFill>
+                            <a:schemeClr val="dk1"/>
+                          </a:solidFill>
+                          <a:latin typeface="+mn-lt"/>
+                          <a:ea typeface="+mn-ea"/>
+                          <a:cs typeface="+mn-cs"/>
+                        </a:rPr>
+                        <a:t>PROFICIENCIA_9EF_LP</a:t>
+                      </a:r>
+                      <a:endParaRPr lang="pt-BR" sz="1200" kern="1200" dirty="0">
+                        <a:solidFill>
+                          <a:schemeClr val="dk1"/>
+                        </a:solidFill>
+                        <a:latin typeface="+mn-lt"/>
+                        <a:ea typeface="+mn-ea"/>
+                        <a:cs typeface="+mn-cs"/>
+                      </a:endParaRPr>
+                    </a:p>
+                  </a:txBody>
+                  <a:tcPr/>
+                </a:tc>
+              </a:tr>
+              <a:tr h="0">
+                <a:tc>
+                  <a:txBody>
+                    <a:bodyPr/>
+                    <a:lstStyle/>
+                    <a:p>
+                      <a:r>
+                        <a:rPr lang="pt-BR" sz="1200" kern="1200" dirty="0" smtClean="0">
+                          <a:solidFill>
+                            <a:schemeClr val="dk1"/>
+                          </a:solidFill>
+                          <a:latin typeface="+mn-lt"/>
+                          <a:ea typeface="+mn-ea"/>
+                          <a:cs typeface="+mn-cs"/>
+                        </a:rPr>
+                        <a:t>media_9EF_LP</a:t>
+                      </a:r>
+                      <a:endParaRPr lang="pt-BR" sz="1200" kern="1200" dirty="0">
+                        <a:solidFill>
+                          <a:schemeClr val="dk1"/>
+                        </a:solidFill>
+                        <a:latin typeface="+mn-lt"/>
+                        <a:ea typeface="+mn-ea"/>
+                        <a:cs typeface="+mn-cs"/>
+                      </a:endParaRPr>
+                    </a:p>
+                  </a:txBody>
+                  <a:tcPr/>
+                </a:tc>
+              </a:tr>
+              <a:tr h="0">
+                <a:tc>
+                  <a:txBody>
+                    <a:bodyPr/>
+                    <a:lstStyle/>
+                    <a:p>
+                      <a:r>
+                        <a:rPr lang="pt-BR" sz="1200" kern="1200" dirty="0" smtClean="0">
+                          <a:solidFill>
+                            <a:schemeClr val="dk1"/>
+                          </a:solidFill>
+                          <a:latin typeface="+mn-lt"/>
+                          <a:ea typeface="+mn-ea"/>
+                          <a:cs typeface="+mn-cs"/>
+                        </a:rPr>
+                        <a:t>Abaixo_do_Básico_LP</a:t>
+                      </a:r>
+                      <a:endParaRPr lang="pt-BR" sz="1200" kern="1200" dirty="0">
+                        <a:solidFill>
+                          <a:schemeClr val="dk1"/>
+                        </a:solidFill>
+                        <a:latin typeface="+mn-lt"/>
+                        <a:ea typeface="+mn-ea"/>
+                        <a:cs typeface="+mn-cs"/>
+                      </a:endParaRPr>
+                    </a:p>
+                  </a:txBody>
+                  <a:tcPr/>
+                </a:tc>
+              </a:tr>
+            </a:tbl>
+          </a:graphicData>
+        </a:graphic>
+      </p:graphicFrame>
+      <p:graphicFrame>
+        <p:nvGraphicFramePr>
+          <p:cNvPr id="9" name="Tabela 8"/>
+          <p:cNvGraphicFramePr>
+            <a:graphicFrameLocks noGrp="1"/>
+          </p:cNvGraphicFramePr>
+          <p:nvPr/>
+        </p:nvGraphicFramePr>
+        <p:xfrm>
+          <a:off x="590203" y="4459007"/>
+          <a:ext cx="3323243" cy="1701213"/>
+        </p:xfrm>
+        <a:graphic>
+          <a:graphicData uri="http://schemas.openxmlformats.org/drawingml/2006/table">
+            <a:tbl>
+              <a:tblPr firstRow="1" bandRow="1">
+                <a:tableStyleId>{5C22544A-7EE6-4342-B048-85BDC9FD1C3A}</a:tableStyleId>
+              </a:tblPr>
+              <a:tblGrid>
+                <a:gridCol w="3323243"/>
+              </a:tblGrid>
+              <a:tr h="329613">
+                <a:tc>
+                  <a:txBody>
+                    <a:bodyPr/>
+                    <a:lstStyle/>
+                    <a:p>
+                      <a:r>
+                        <a:rPr lang="pt-BR" sz="1200" b="1" kern="1200" dirty="0" smtClean="0">
+                          <a:solidFill>
+                            <a:schemeClr val="lt1"/>
+                          </a:solidFill>
+                          <a:latin typeface="+mn-lt"/>
+                          <a:ea typeface="+mn-ea"/>
+                          <a:cs typeface="+mn-cs"/>
+                        </a:rPr>
+                        <a:t>Gold.resultado_saeb_por_estado_vs_idhm</a:t>
+                      </a:r>
+                    </a:p>
+                  </a:txBody>
+                  <a:tcPr/>
+                </a:tc>
+              </a:tr>
+              <a:tr h="186392">
+                <a:tc>
+                  <a:txBody>
+                    <a:bodyPr/>
+                    <a:lstStyle/>
+                    <a:p>
+                      <a:r>
+                        <a:rPr lang="pt-BR" sz="1200" kern="1200" dirty="0" smtClean="0">
+                          <a:solidFill>
+                            <a:schemeClr val="dk1"/>
+                          </a:solidFill>
+                          <a:latin typeface="+mn-lt"/>
+                          <a:ea typeface="+mn-ea"/>
+                          <a:cs typeface="+mn-cs"/>
+                        </a:rPr>
+                        <a:t>ESTADO</a:t>
+                      </a:r>
+                      <a:endParaRPr lang="pt-BR" sz="1200" kern="1200" dirty="0">
+                        <a:solidFill>
+                          <a:schemeClr val="dk1"/>
+                        </a:solidFill>
+                        <a:latin typeface="+mn-lt"/>
+                        <a:ea typeface="+mn-ea"/>
+                        <a:cs typeface="+mn-cs"/>
+                      </a:endParaRPr>
+                    </a:p>
+                  </a:txBody>
+                  <a:tcPr/>
+                </a:tc>
+              </a:tr>
+              <a:tr h="186392">
+                <a:tc>
+                  <a:txBody>
+                    <a:bodyPr/>
+                    <a:lstStyle/>
+                    <a:p>
+                      <a:r>
+                        <a:rPr lang="pt-BR" sz="1200" kern="1200" dirty="0" smtClean="0">
+                          <a:solidFill>
+                            <a:schemeClr val="dk1"/>
+                          </a:solidFill>
+                          <a:latin typeface="+mn-lt"/>
+                          <a:ea typeface="+mn-ea"/>
+                          <a:cs typeface="+mn-cs"/>
+                        </a:rPr>
+                        <a:t>MEDIA_9EF_LP</a:t>
+                      </a:r>
+                      <a:endParaRPr lang="pt-BR" sz="1200" kern="1200" dirty="0">
+                        <a:solidFill>
+                          <a:schemeClr val="dk1"/>
+                        </a:solidFill>
+                        <a:latin typeface="+mn-lt"/>
+                        <a:ea typeface="+mn-ea"/>
+                        <a:cs typeface="+mn-cs"/>
+                      </a:endParaRPr>
+                    </a:p>
+                  </a:txBody>
+                  <a:tcPr/>
+                </a:tc>
+              </a:tr>
+              <a:tr h="186392">
+                <a:tc>
+                  <a:txBody>
+                    <a:bodyPr/>
+                    <a:lstStyle/>
+                    <a:p>
+                      <a:r>
+                        <a:rPr lang="pt-BR" sz="1200" kern="1200" dirty="0" smtClean="0">
+                          <a:solidFill>
+                            <a:schemeClr val="dk1"/>
+                          </a:solidFill>
+                          <a:latin typeface="+mn-lt"/>
+                          <a:ea typeface="+mn-ea"/>
+                          <a:cs typeface="+mn-cs"/>
+                        </a:rPr>
+                        <a:t>MEDIA_9EF_MT</a:t>
+                      </a:r>
+                      <a:endParaRPr lang="pt-BR" sz="1200" kern="1200" dirty="0">
+                        <a:solidFill>
+                          <a:schemeClr val="dk1"/>
+                        </a:solidFill>
+                        <a:latin typeface="+mn-lt"/>
+                        <a:ea typeface="+mn-ea"/>
+                        <a:cs typeface="+mn-cs"/>
+                      </a:endParaRPr>
+                    </a:p>
+                  </a:txBody>
+                  <a:tcPr/>
+                </a:tc>
+              </a:tr>
+              <a:tr h="186392">
+                <a:tc>
+                  <a:txBody>
+                    <a:bodyPr/>
+                    <a:lstStyle/>
+                    <a:p>
+                      <a:r>
+                        <a:rPr lang="pt-BR" sz="1200" kern="1200" dirty="0" smtClean="0">
+                          <a:solidFill>
+                            <a:schemeClr val="dk1"/>
+                          </a:solidFill>
+                          <a:latin typeface="+mn-lt"/>
+                          <a:ea typeface="+mn-ea"/>
+                          <a:cs typeface="+mn-cs"/>
+                        </a:rPr>
+                        <a:t>MEDIA_SAEB_9EF</a:t>
+                      </a:r>
+                      <a:endParaRPr lang="pt-BR" sz="1200" kern="1200" dirty="0">
+                        <a:solidFill>
+                          <a:schemeClr val="dk1"/>
+                        </a:solidFill>
+                        <a:latin typeface="+mn-lt"/>
+                        <a:ea typeface="+mn-ea"/>
+                        <a:cs typeface="+mn-cs"/>
+                      </a:endParaRPr>
+                    </a:p>
+                  </a:txBody>
+                  <a:tcPr/>
+                </a:tc>
+              </a:tr>
+              <a:tr h="186392">
+                <a:tc>
+                  <a:txBody>
+                    <a:bodyPr/>
+                    <a:lstStyle/>
+                    <a:p>
+                      <a:r>
+                        <a:rPr lang="pt-BR" sz="1200" kern="1200" dirty="0" smtClean="0">
+                          <a:solidFill>
+                            <a:schemeClr val="dk1"/>
+                          </a:solidFill>
+                          <a:latin typeface="+mn-lt"/>
+                          <a:ea typeface="+mn-ea"/>
+                          <a:cs typeface="+mn-cs"/>
+                        </a:rPr>
+                        <a:t>IDHM</a:t>
+                      </a:r>
+                      <a:endParaRPr lang="pt-BR" sz="1200" kern="1200" dirty="0">
+                        <a:solidFill>
+                          <a:schemeClr val="dk1"/>
+                        </a:solidFill>
+                        <a:latin typeface="+mn-lt"/>
+                        <a:ea typeface="+mn-ea"/>
+                        <a:cs typeface="+mn-cs"/>
+                      </a:endParaRPr>
+                    </a:p>
+                  </a:txBody>
+                  <a:tcPr/>
+                </a:tc>
+              </a:tr>
+            </a:tbl>
+          </a:graphicData>
+        </a:graphic>
+      </p:graphicFrame>
+      <p:cxnSp>
+        <p:nvCxnSpPr>
+          <p:cNvPr id="11" name="Conector angulado 10"/>
+          <p:cNvCxnSpPr>
+            <a:stCxn id="5" idx="1"/>
+            <a:endCxn id="18" idx="3"/>
+          </p:cNvCxnSpPr>
+          <p:nvPr/>
+        </p:nvCxnSpPr>
+        <p:spPr>
+          <a:xfrm rot="10800000">
+            <a:off x="3507970" y="1022466"/>
+            <a:ext cx="1200726" cy="1539855"/>
+          </a:xfrm>
+          <a:prstGeom prst="bentConnector3">
+            <a:avLst>
+              <a:gd name="adj1" fmla="val 50000"/>
+            </a:avLst>
+          </a:prstGeom>
+          <a:ln>
+            <a:tailEnd type="triangle"/>
+          </a:ln>
+        </p:spPr>
+        <p:style>
+          <a:lnRef idx="1">
+            <a:schemeClr val="accent1"/>
+          </a:lnRef>
+          <a:fillRef idx="0">
+            <a:schemeClr val="accent1"/>
+          </a:fillRef>
+          <a:effectRef idx="0">
+            <a:schemeClr val="accent1"/>
+          </a:effectRef>
+          <a:fontRef idx="minor">
+            <a:schemeClr val="tx1"/>
+          </a:fontRef>
+        </p:style>
+      </p:cxnSp>
+      <p:sp>
+        <p:nvSpPr>
+          <p:cNvPr id="18" name="Retângulo 17"/>
+          <p:cNvSpPr/>
+          <p:nvPr/>
+        </p:nvSpPr>
+        <p:spPr>
+          <a:xfrm>
+            <a:off x="3424844" y="931025"/>
+            <a:ext cx="83126" cy="182880"/>
+          </a:xfrm>
+          <a:prstGeom prst="rect">
+            <a:avLst/>
+          </a:prstGeom>
+          <a:noFill/>
+          <a:ln>
+            <a:noFill/>
+          </a:ln>
+        </p:spPr>
+        <p:style>
+          <a:lnRef idx="2">
+            <a:schemeClr val="accent1">
+              <a:shade val="50000"/>
+            </a:schemeClr>
+          </a:lnRef>
+          <a:fillRef idx="1">
+            <a:schemeClr val="accent1"/>
+          </a:fillRef>
+          <a:effectRef idx="0">
+            <a:schemeClr val="accent1"/>
+          </a:effectRef>
+          <a:fontRef idx="minor">
+            <a:schemeClr val="lt1"/>
+          </a:fontRef>
+        </p:style>
+        <p:txBody>
+          <a:bodyPr rtlCol="0" anchor="ctr"/>
+          <a:lstStyle/>
+          <a:p>
+            <a:pPr algn="ctr"/>
+            <a:endParaRPr lang="pt-BR"/>
+          </a:p>
+        </p:txBody>
+      </p:sp>
+      <p:sp>
+        <p:nvSpPr>
+          <p:cNvPr id="20" name="Retângulo 19"/>
+          <p:cNvSpPr/>
+          <p:nvPr/>
+        </p:nvSpPr>
+        <p:spPr>
+          <a:xfrm>
+            <a:off x="3816927" y="4840778"/>
+            <a:ext cx="83126" cy="182880"/>
+          </a:xfrm>
+          <a:prstGeom prst="rect">
+            <a:avLst/>
+          </a:prstGeom>
+          <a:noFill/>
+          <a:ln>
+            <a:noFill/>
+          </a:ln>
+        </p:spPr>
+        <p:style>
+          <a:lnRef idx="2">
+            <a:schemeClr val="accent1">
+              <a:shade val="50000"/>
+            </a:schemeClr>
+          </a:lnRef>
+          <a:fillRef idx="1">
+            <a:schemeClr val="accent1"/>
+          </a:fillRef>
+          <a:effectRef idx="0">
+            <a:schemeClr val="accent1"/>
+          </a:effectRef>
+          <a:fontRef idx="minor">
+            <a:schemeClr val="lt1"/>
+          </a:fontRef>
+        </p:style>
+        <p:txBody>
+          <a:bodyPr rtlCol="0" anchor="ctr"/>
+          <a:lstStyle/>
+          <a:p>
+            <a:pPr algn="ctr"/>
+            <a:endParaRPr lang="pt-BR"/>
+          </a:p>
+        </p:txBody>
+      </p:sp>
+      <p:sp>
+        <p:nvSpPr>
+          <p:cNvPr id="21" name="Retângulo 20"/>
+          <p:cNvSpPr/>
+          <p:nvPr/>
+        </p:nvSpPr>
+        <p:spPr>
+          <a:xfrm>
+            <a:off x="7873075" y="1210116"/>
+            <a:ext cx="83126" cy="182880"/>
+          </a:xfrm>
+          <a:prstGeom prst="rect">
+            <a:avLst/>
+          </a:prstGeom>
+          <a:noFill/>
+          <a:ln>
+            <a:noFill/>
+          </a:ln>
+        </p:spPr>
+        <p:style>
+          <a:lnRef idx="2">
+            <a:schemeClr val="accent1">
+              <a:shade val="50000"/>
+            </a:schemeClr>
+          </a:lnRef>
+          <a:fillRef idx="1">
+            <a:schemeClr val="accent1"/>
+          </a:fillRef>
+          <a:effectRef idx="0">
+            <a:schemeClr val="accent1"/>
+          </a:effectRef>
+          <a:fontRef idx="minor">
+            <a:schemeClr val="lt1"/>
+          </a:fontRef>
+        </p:style>
+        <p:txBody>
+          <a:bodyPr rtlCol="0" anchor="ctr"/>
+          <a:lstStyle/>
+          <a:p>
+            <a:pPr algn="ctr"/>
+            <a:endParaRPr lang="pt-BR"/>
+          </a:p>
+        </p:txBody>
+      </p:sp>
+      <p:cxnSp>
+        <p:nvCxnSpPr>
+          <p:cNvPr id="23" name="Conector angulado 22"/>
+          <p:cNvCxnSpPr>
+            <a:stCxn id="5" idx="3"/>
+            <a:endCxn id="21" idx="1"/>
+          </p:cNvCxnSpPr>
+          <p:nvPr/>
+        </p:nvCxnSpPr>
+        <p:spPr>
+          <a:xfrm flipV="1">
+            <a:off x="7065816" y="1301556"/>
+            <a:ext cx="807259" cy="1260764"/>
+          </a:xfrm>
+          <a:prstGeom prst="bentConnector3">
+            <a:avLst>
+              <a:gd name="adj1" fmla="val 50000"/>
+            </a:avLst>
+          </a:prstGeom>
+          <a:ln>
+            <a:tailEnd type="triangle"/>
+          </a:ln>
+        </p:spPr>
+        <p:style>
+          <a:lnRef idx="1">
+            <a:schemeClr val="accent1"/>
+          </a:lnRef>
+          <a:fillRef idx="0">
+            <a:schemeClr val="accent1"/>
+          </a:fillRef>
+          <a:effectRef idx="0">
+            <a:schemeClr val="accent1"/>
+          </a:effectRef>
+          <a:fontRef idx="minor">
+            <a:schemeClr val="tx1"/>
+          </a:fontRef>
+        </p:style>
+      </p:cxnSp>
+      <p:cxnSp>
+        <p:nvCxnSpPr>
+          <p:cNvPr id="27" name="Conector angulado 26"/>
+          <p:cNvCxnSpPr>
+            <a:stCxn id="5" idx="1"/>
+            <a:endCxn id="20" idx="3"/>
+          </p:cNvCxnSpPr>
+          <p:nvPr/>
+        </p:nvCxnSpPr>
+        <p:spPr>
+          <a:xfrm rot="10800000" flipV="1">
+            <a:off x="3900054" y="2562320"/>
+            <a:ext cx="808643" cy="2369898"/>
+          </a:xfrm>
+          <a:prstGeom prst="bentConnector3">
+            <a:avLst>
+              <a:gd name="adj1" fmla="val 50000"/>
+            </a:avLst>
+          </a:prstGeom>
+          <a:ln>
+            <a:tailEnd type="triangle"/>
+          </a:ln>
+        </p:spPr>
+        <p:style>
+          <a:lnRef idx="1">
+            <a:schemeClr val="accent1"/>
+          </a:lnRef>
+          <a:fillRef idx="0">
+            <a:schemeClr val="accent1"/>
+          </a:fillRef>
+          <a:effectRef idx="0">
+            <a:schemeClr val="accent1"/>
+          </a:effectRef>
+          <a:fontRef idx="minor">
+            <a:schemeClr val="tx1"/>
+          </a:fontRef>
+        </p:style>
+      </p:cxnSp>
+    </p:spTree>
+    <p:extLst>
+      <p:ext uri="{BB962C8B-B14F-4D97-AF65-F5344CB8AC3E}">
+        <p14:creationId xmlns:p14="http://schemas.microsoft.com/office/powerpoint/2010/main" val="2045756094"/>
       </p:ext>
     </p:extLst>
   </p:cSld>

</xml_diff>